<commit_message>
feat: integrate A+B into single Cell Stem Cell Perspective
- Rewrote create_perspective_docx.py with focused narrative:
  1. Controllable factors remain uncontrolled
  2. PSCs are uniquely vulnerable (5 evidence lines)
  3. GEO seasonality = Japan fiscal year-end artifact
  4. Prospective monitoring needed
- ~4,000 words (within CSS 4,000-5,500 limit)
- 2 figures + graphical abstract
- 26 references, Vancouver superscript
- Highlights (4x85 chars) + eTOC blurb included
- Generated PPTX (3 slides: Fig1 natural experiment, Fig2 roadmap, GA)

Co-Authored-By: Tatsuki Onishi <bougtoir@gmail.com>
</commit_message>
<xml_diff>
--- a/stem_cell_seasonality/output/CellStemCell_Figures_InvisibleVariables.pptx
+++ b/stem_cell_seasonality/output/CellStemCell_Figures_InvisibleVariables.pptx
@@ -3098,7 +3098,7 @@
         </p:nvSpPr>
         <p:spPr>
           <a:xfrm>
-            <a:off x="457200" y="274320"/>
+            <a:off x="457200" y="182880"/>
             <a:ext cx="10972800" cy="548640"/>
           </a:xfrm>
           <a:prstGeom prst="rect">
@@ -3112,23 +3112,53 @@
           </a:bodyPr>
           <a:lstStyle/>
           <a:p>
-            <a:r>
-              <a:rPr sz="1800" b="1"/>
-              <a:t>Figure 1. The Environmental Iceberg of Stem Cell Culture</a:t>
-            </a:r>
-          </a:p>
-        </p:txBody>
-      </p:sp>
-      <p:sp>
-        <p:nvSpPr>
-          <p:cNvPr id="3" name="TextBox 2"/>
+            <a:pPr>
+              <a:defRPr sz="1800" b="1">
+                <a:solidFill>
+                  <a:srgbClr val="003366"/>
+                </a:solidFill>
+              </a:defRPr>
+            </a:pPr>
+            <a:r>
+              <a:t>Figure 1. Academic Calendar Variation as a Natural Experiment</a:t>
+            </a:r>
+          </a:p>
+        </p:txBody>
+      </p:sp>
+      <p:pic>
+        <p:nvPicPr>
+          <p:cNvPr id="3" name="Picture 2" descr="natural_experiment_figure.png"/>
+          <p:cNvPicPr>
+            <a:picLocks noChangeAspect="1"/>
+          </p:cNvPicPr>
+          <p:nvPr/>
+        </p:nvPicPr>
+        <p:blipFill>
+          <a:blip r:embed="rId2"/>
+          <a:stretch>
+            <a:fillRect/>
+          </a:stretch>
+        </p:blipFill>
+        <p:spPr>
+          <a:xfrm>
+            <a:off x="457200" y="822960"/>
+            <a:ext cx="11247120" cy="9697736"/>
+          </a:xfrm>
+          <a:prstGeom prst="rect">
+            <a:avLst/>
+          </a:prstGeom>
+        </p:spPr>
+      </p:pic>
+      <p:sp>
+        <p:nvSpPr>
+          <p:cNvPr id="4" name="TextBox 3"/>
           <p:cNvSpPr txBox="1"/>
           <p:nvPr/>
         </p:nvSpPr>
         <p:spPr>
           <a:xfrm>
-            <a:off x="914400" y="2743200"/>
-            <a:ext cx="10058400" cy="914400"/>
+            <a:off x="457200" y="5760720"/>
+            <a:ext cx="10972800" cy="1097280"/>
           </a:xfrm>
           <a:prstGeom prst="rect">
             <a:avLst/>
@@ -3136,14 +3166,20 @@
           <a:noFill/>
         </p:spPr>
         <p:txBody>
-          <a:bodyPr wrap="none">
+          <a:bodyPr wrap="square">
             <a:spAutoFit/>
           </a:bodyPr>
           <a:lstStyle/>
           <a:p>
-            <a:r>
-              <a:rPr sz="1400" i="1"/>
-              <a:t>[Conceptual diagram — controlled vs uncontrolled environmental variables]</a:t>
+            <a:pPr>
+              <a:defRPr sz="1100">
+                <a:solidFill>
+                  <a:srgbClr val="333333"/>
+                </a:solidFill>
+              </a:defRPr>
+            </a:pPr>
+            <a:r>
+              <a:t>(A) Normalized monthly distributions by academic year group. (B) Country-level heatmap. (C) Circular mean directions (Rayleigh vectors). (D) Statistical summary. n=6,101 total; 3,195 with country affiliation.</a:t>
             </a:r>
           </a:p>
         </p:txBody>
@@ -3174,7 +3210,7 @@
         </p:nvSpPr>
         <p:spPr>
           <a:xfrm>
-            <a:off x="457200" y="274320"/>
+            <a:off x="457200" y="182880"/>
             <a:ext cx="10972800" cy="548640"/>
           </a:xfrm>
           <a:prstGeom prst="rect">
@@ -3188,8 +3224,14 @@
           </a:bodyPr>
           <a:lstStyle/>
           <a:p>
-            <a:r>
-              <a:rPr sz="1800" b="1"/>
+            <a:pPr>
+              <a:defRPr sz="1800" b="1">
+                <a:solidFill>
+                  <a:srgbClr val="003366"/>
+                </a:solidFill>
+              </a:defRPr>
+            </a:pPr>
+            <a:r>
               <a:t>Figure 2. Research Roadmap for Environmental Profiling</a:t>
             </a:r>
           </a:p>
@@ -3203,8 +3245,8 @@
         </p:nvSpPr>
         <p:spPr>
           <a:xfrm>
-            <a:off x="914400" y="2743200"/>
-            <a:ext cx="10058400" cy="914400"/>
+            <a:off x="457200" y="914400"/>
+            <a:ext cx="5486400" cy="5029200"/>
           </a:xfrm>
           <a:prstGeom prst="rect">
             <a:avLst/>
@@ -3212,14 +3254,245 @@
           <a:noFill/>
         </p:spPr>
         <p:txBody>
-          <a:bodyPr wrap="none">
+          <a:bodyPr wrap="square">
             <a:spAutoFit/>
           </a:bodyPr>
           <a:lstStyle/>
           <a:p>
-            <a:r>
-              <a:rPr sz="1400" i="1"/>
-              <a:t>[Evidence matrix + 3-phase investigation strategy]</a:t>
+            <a:pPr>
+              <a:defRPr sz="1400" b="1"/>
+            </a:pPr>
+            <a:r>
+              <a:t>A. Evidence Matrix</a:t>
+            </a:r>
+          </a:p>
+          <a:p>
+            <a:pPr>
+              <a:spcAft>
+                <a:spcPts val="400"/>
+              </a:spcAft>
+              <a:defRPr sz="1100"/>
+            </a:pPr>
+            <a:r>
+              <a:t>• Humidity/Osmolarity: Direct PSC evidence [Inverted]</a:t>
+            </a:r>
+          </a:p>
+          <a:p>
+            <a:pPr>
+              <a:spcAft>
+                <a:spcPts val="400"/>
+              </a:spcAft>
+              <a:defRPr sz="1100"/>
+            </a:pPr>
+            <a:r>
+              <a:t>• VOCs: Direct IVF + PSC evidence [Inverted]</a:t>
+            </a:r>
+          </a:p>
+          <a:p>
+            <a:pPr>
+              <a:spcAft>
+                <a:spcPts val="400"/>
+              </a:spcAft>
+              <a:defRPr sz="1100"/>
+            </a:pPr>
+            <a:r>
+              <a:t>• Photoperiod/Light: Indirect (CRY1, IVF) [Inverted]</a:t>
+            </a:r>
+          </a:p>
+          <a:p>
+            <a:pPr>
+              <a:spcAft>
+                <a:spcPts val="400"/>
+              </a:spcAft>
+              <a:defRPr sz="1100"/>
+            </a:pPr>
+            <a:r>
+              <a:t>• EMF (50/60 Hz): Direct ESC evidence [N/A]</a:t>
+            </a:r>
+          </a:p>
+          <a:p>
+            <a:pPr>
+              <a:spcAft>
+                <a:spcPts val="400"/>
+              </a:spcAft>
+              <a:defRPr sz="1100"/>
+            </a:pPr>
+            <a:r>
+              <a:t>• Barometric pressure: Theoretical [Synchronous]</a:t>
+            </a:r>
+          </a:p>
+          <a:p>
+            <a:pPr>
+              <a:spcAft>
+                <a:spcPts val="400"/>
+              </a:spcAft>
+              <a:defRPr sz="1100"/>
+            </a:pPr>
+            <a:r>
+              <a:t>• Cosmic rays: Indirect (fibroblast) [Synchronous]</a:t>
+            </a:r>
+          </a:p>
+        </p:txBody>
+      </p:sp>
+      <p:sp>
+        <p:nvSpPr>
+          <p:cNvPr id="4" name="TextBox 3"/>
+          <p:cNvSpPr txBox="1"/>
+          <p:nvPr/>
+        </p:nvSpPr>
+        <p:spPr>
+          <a:xfrm>
+            <a:off x="6217920" y="914400"/>
+            <a:ext cx="5486400" cy="5029200"/>
+          </a:xfrm>
+          <a:prstGeom prst="rect">
+            <a:avLst/>
+          </a:prstGeom>
+          <a:noFill/>
+        </p:spPr>
+        <p:txBody>
+          <a:bodyPr wrap="square">
+            <a:spAutoFit/>
+          </a:bodyPr>
+          <a:lstStyle/>
+          <a:p>
+            <a:pPr>
+              <a:defRPr sz="1400" b="1"/>
+            </a:pPr>
+            <a:r>
+              <a:t>B. Three-Phase Strategy</a:t>
+            </a:r>
+          </a:p>
+          <a:p>
+            <a:pPr>
+              <a:spcBef>
+                <a:spcPts val="1200"/>
+              </a:spcBef>
+              <a:defRPr sz="1200" b="1"/>
+            </a:pPr>
+            <a:r>
+              <a:t>Phase I: Passive Monitoring</a:t>
+            </a:r>
+          </a:p>
+          <a:p>
+            <a:pPr>
+              <a:spcAft>
+                <a:spcPts val="200"/>
+              </a:spcAft>
+              <a:defRPr sz="1000"/>
+            </a:pPr>
+            <a:r>
+              <a:t>  → Multi-parameter IoT sensors</a:t>
+            </a:r>
+          </a:p>
+          <a:p>
+            <a:pPr>
+              <a:spcAft>
+                <a:spcPts val="200"/>
+              </a:spcAft>
+              <a:defRPr sz="1000"/>
+            </a:pPr>
+            <a:r>
+              <a:t>  → 12 months continuous</a:t>
+            </a:r>
+          </a:p>
+          <a:p>
+            <a:pPr>
+              <a:spcAft>
+                <a:spcPts val="200"/>
+              </a:spcAft>
+              <a:defRPr sz="1000"/>
+            </a:pPr>
+            <a:r>
+              <a:t>  → Paired with differentiation outcomes</a:t>
+            </a:r>
+          </a:p>
+          <a:p>
+            <a:pPr>
+              <a:spcBef>
+                <a:spcPts val="1200"/>
+              </a:spcBef>
+              <a:defRPr sz="1200" b="1"/>
+            </a:pPr>
+            <a:r>
+              <a:t>Phase II: Registry Mining</a:t>
+            </a:r>
+          </a:p>
+          <a:p>
+            <a:pPr>
+              <a:spcAft>
+                <a:spcPts val="200"/>
+              </a:spcAft>
+              <a:defRPr sz="1000"/>
+            </a:pPr>
+            <a:r>
+              <a:t>  → HFEA (UK, 51°N)</a:t>
+            </a:r>
+          </a:p>
+          <a:p>
+            <a:pPr>
+              <a:spcAft>
+                <a:spcPts val="200"/>
+              </a:spcAft>
+              <a:defRPr sz="1000"/>
+            </a:pPr>
+            <a:r>
+              <a:t>  → ANZARD (Australia, 33°S)</a:t>
+            </a:r>
+          </a:p>
+          <a:p>
+            <a:pPr>
+              <a:spcAft>
+                <a:spcPts val="200"/>
+              </a:spcAft>
+              <a:defRPr sz="1000"/>
+            </a:pPr>
+            <a:r>
+              <a:t>  → Hemisphere-inversion test</a:t>
+            </a:r>
+          </a:p>
+          <a:p>
+            <a:pPr>
+              <a:spcBef>
+                <a:spcPts val="1200"/>
+              </a:spcBef>
+              <a:defRPr sz="1200" b="1"/>
+            </a:pPr>
+            <a:r>
+              <a:t>Phase III: Controlled Intervention</a:t>
+            </a:r>
+          </a:p>
+          <a:p>
+            <a:pPr>
+              <a:spcAft>
+                <a:spcPts val="200"/>
+              </a:spcAft>
+              <a:defRPr sz="1000"/>
+            </a:pPr>
+            <a:r>
+              <a:t>  → Humidity-controlled incubators</a:t>
+            </a:r>
+          </a:p>
+          <a:p>
+            <a:pPr>
+              <a:spcAft>
+                <a:spcPts val="200"/>
+              </a:spcAft>
+              <a:defRPr sz="1000"/>
+            </a:pPr>
+            <a:r>
+              <a:t>  → Light-tight biosafety cabinets</a:t>
+            </a:r>
+          </a:p>
+          <a:p>
+            <a:pPr>
+              <a:spcAft>
+                <a:spcPts val="200"/>
+              </a:spcAft>
+              <a:defRPr sz="1000"/>
+            </a:pPr>
+            <a:r>
+              <a:t>  → EMF shielding</a:t>
             </a:r>
           </a:p>
         </p:txBody>
@@ -3250,8 +3523,8 @@
         </p:nvSpPr>
         <p:spPr>
           <a:xfrm>
-            <a:off x="457200" y="91440"/>
-            <a:ext cx="10972800" cy="457200"/>
+            <a:off x="457200" y="182880"/>
+            <a:ext cx="10972800" cy="548640"/>
           </a:xfrm>
           <a:prstGeom prst="rect">
             <a:avLst/>
@@ -3264,16 +3537,22 @@
           </a:bodyPr>
           <a:lstStyle/>
           <a:p>
-            <a:r>
-              <a:rPr sz="1600" b="1"/>
-              <a:t>Figure 3. Natural Experiment: Academic Calendar vs Biological Seasonality</a:t>
+            <a:pPr>
+              <a:defRPr sz="1800" b="1">
+                <a:solidFill>
+                  <a:srgbClr val="003366"/>
+                </a:solidFill>
+              </a:defRPr>
+            </a:pPr>
+            <a:r>
+              <a:t>Graphical Abstract</a:t>
             </a:r>
           </a:p>
         </p:txBody>
       </p:sp>
       <p:pic>
         <p:nvPicPr>
-          <p:cNvPr id="3" name="Picture 2" descr="natural_experiment_figure.png"/>
+          <p:cNvPr id="3" name="Picture 2" descr="Graphical_Abstract.png"/>
           <p:cNvPicPr>
             <a:picLocks noChangeAspect="1"/>
           </p:cNvPicPr>
@@ -3287,43 +3566,14 @@
         </p:blipFill>
         <p:spPr>
           <a:xfrm>
-            <a:off x="274320" y="640080"/>
-            <a:ext cx="11430000" cy="9855423"/>
+            <a:off x="2286000" y="731520"/>
+            <a:ext cx="7315200" cy="7315200"/>
           </a:xfrm>
           <a:prstGeom prst="rect">
             <a:avLst/>
           </a:prstGeom>
         </p:spPr>
       </p:pic>
-      <p:sp>
-        <p:nvSpPr>
-          <p:cNvPr id="4" name="TextBox 3"/>
-          <p:cNvSpPr txBox="1"/>
-          <p:nvPr/>
-        </p:nvSpPr>
-        <p:spPr>
-          <a:xfrm>
-            <a:off x="457200" y="6217920"/>
-            <a:ext cx="10972800" cy="640080"/>
-          </a:xfrm>
-          <a:prstGeom prst="rect">
-            <a:avLst/>
-          </a:prstGeom>
-          <a:noFill/>
-        </p:spPr>
-        <p:txBody>
-          <a:bodyPr wrap="square">
-            <a:spAutoFit/>
-          </a:bodyPr>
-          <a:lstStyle/>
-          <a:p>
-            <a:r>
-              <a:rPr sz="1000"/>
-              <a:t>Japan/Korea (Mar/Apr start) shows March peak (p=0.0006); USA/EU/CN (Sep/Oct start) shows no seasonality (p=0.15). Sensitivity: removing Japan eliminates March peak.</a:t>
-            </a:r>
-          </a:p>
-        </p:txBody>
-      </p:sp>
     </p:spTree>
   </p:cSld>
   <p:clrMapOvr>

</xml_diff>